<commit_message>
docs: update reports and generated project deliverables
</commit_message>
<xml_diff>
--- a/deliverables/RGU_Internship_Defense_Presentation.pptx
+++ b/deliverables/RGU_Internship_Defense_Presentation.pptx
@@ -5,18 +5,18 @@
     <p:sldMasterId id="2147483648" r:id="rId1"/>
   </p:sldMasterIdLst>
   <p:sldIdLst>
-    <p:sldId id="256" r:id="rId7"/>
-    <p:sldId id="257" r:id="rId8"/>
-    <p:sldId id="258" r:id="rId9"/>
-    <p:sldId id="259" r:id="rId10"/>
-    <p:sldId id="260" r:id="rId11"/>
-    <p:sldId id="261" r:id="rId12"/>
-    <p:sldId id="262" r:id="rId13"/>
-    <p:sldId id="263" r:id="rId14"/>
-    <p:sldId id="264" r:id="rId15"/>
-    <p:sldId id="265" r:id="rId16"/>
+    <p:sldId id="256" r:id="rId2"/>
+    <p:sldId id="257" r:id="rId3"/>
+    <p:sldId id="258" r:id="rId4"/>
+    <p:sldId id="259" r:id="rId5"/>
+    <p:sldId id="260" r:id="rId6"/>
+    <p:sldId id="261" r:id="rId7"/>
+    <p:sldId id="262" r:id="rId8"/>
+    <p:sldId id="263" r:id="rId9"/>
+    <p:sldId id="264" r:id="rId10"/>
+    <p:sldId id="265" r:id="rId11"/>
   </p:sldIdLst>
-  <p:sldSz cx="12191695" cy="6858000" type="screen4x3"/>
+  <p:sldSz cx="12192000" cy="6858000"/>
   <p:notesSz cx="6858000" cy="9144000"/>
   <p:defaultTextStyle>
     <a:defPPr>
@@ -113,6 +113,22 @@
       </a:defRPr>
     </a:lvl9pPr>
   </p:defaultTextStyle>
+  <p:extLst>
+    <p:ext uri="{EFAFB233-063F-42B5-8137-9DF3F51BA10A}">
+      <p15:sldGuideLst xmlns:p15="http://schemas.microsoft.com/office/powerpoint/2012/main">
+        <p15:guide id="1" orient="horz" pos="2160">
+          <p15:clr>
+            <a:srgbClr val="A4A3A4"/>
+          </p15:clr>
+        </p15:guide>
+        <p15:guide id="2" pos="2880">
+          <p15:clr>
+            <a:srgbClr val="A4A3A4"/>
+          </p15:clr>
+        </p15:guide>
+      </p15:sldGuideLst>
+    </p:ext>
+  </p:extLst>
 </p:presentation>
 </file>
 
@@ -154,10 +170,9 @@
           <a:lstStyle/>
           <a:p>
             <a:r>
-              <a:rPr lang="en-US" smtClean="0"/>
+              <a:rPr lang="en-US"/>
               <a:t>Click to edit Master title style</a:t>
             </a:r>
-            <a:endParaRPr lang="en-US"/>
           </a:p>
         </p:txBody>
       </p:sp>
@@ -273,10 +288,9 @@
           </a:lstStyle>
           <a:p>
             <a:r>
-              <a:rPr lang="en-US" smtClean="0"/>
+              <a:rPr lang="en-US"/>
               <a:t>Click to edit Master subtitle style</a:t>
             </a:r>
-            <a:endParaRPr lang="en-US"/>
           </a:p>
         </p:txBody>
       </p:sp>
@@ -297,7 +311,7 @@
           <a:p>
             <a:fld id="{5BCAD085-E8A6-8845-BD4E-CB4CCA059FC4}" type="datetimeFigureOut">
               <a:rPr lang="en-US" smtClean="0"/>
-              <a:t>1/27/13</a:t>
+              <a:t>6/8/26</a:t>
             </a:fld>
             <a:endParaRPr lang="en-US"/>
           </a:p>
@@ -339,7 +353,7 @@
           <a:p>
             <a:fld id="{C1FF6DA9-008F-8B48-92A6-B652298478BF}" type="slidenum">
               <a:rPr lang="en-US" smtClean="0"/>
-              <a:t>‹#›</a:t>
+              <a:t>‹N°›</a:t>
             </a:fld>
             <a:endParaRPr lang="en-US"/>
           </a:p>
@@ -391,10 +405,9 @@
           <a:lstStyle/>
           <a:p>
             <a:r>
-              <a:rPr lang="en-US" smtClean="0"/>
+              <a:rPr lang="en-US"/>
               <a:t>Click to edit Master title style</a:t>
             </a:r>
-            <a:endParaRPr lang="en-US"/>
           </a:p>
         </p:txBody>
       </p:sp>
@@ -415,38 +428,37 @@
           <a:p>
             <a:pPr lvl="0"/>
             <a:r>
-              <a:rPr lang="en-US" smtClean="0"/>
+              <a:rPr lang="en-US"/>
               <a:t>Click to edit Master text styles</a:t>
             </a:r>
           </a:p>
           <a:p>
             <a:pPr lvl="1"/>
             <a:r>
-              <a:rPr lang="en-US" smtClean="0"/>
+              <a:rPr lang="en-US"/>
               <a:t>Second level</a:t>
             </a:r>
           </a:p>
           <a:p>
             <a:pPr lvl="2"/>
             <a:r>
-              <a:rPr lang="en-US" smtClean="0"/>
+              <a:rPr lang="en-US"/>
               <a:t>Third level</a:t>
             </a:r>
           </a:p>
           <a:p>
             <a:pPr lvl="3"/>
             <a:r>
-              <a:rPr lang="en-US" smtClean="0"/>
+              <a:rPr lang="en-US"/>
               <a:t>Fourth level</a:t>
             </a:r>
           </a:p>
           <a:p>
             <a:pPr lvl="4"/>
             <a:r>
-              <a:rPr lang="en-US" smtClean="0"/>
+              <a:rPr lang="en-US"/>
               <a:t>Fifth level</a:t>
             </a:r>
-            <a:endParaRPr lang="en-US"/>
           </a:p>
         </p:txBody>
       </p:sp>
@@ -467,7 +479,7 @@
           <a:p>
             <a:fld id="{5BCAD085-E8A6-8845-BD4E-CB4CCA059FC4}" type="datetimeFigureOut">
               <a:rPr lang="en-US" smtClean="0"/>
-              <a:t>1/27/13</a:t>
+              <a:t>6/8/26</a:t>
             </a:fld>
             <a:endParaRPr lang="en-US"/>
           </a:p>
@@ -509,7 +521,7 @@
           <a:p>
             <a:fld id="{C1FF6DA9-008F-8B48-92A6-B652298478BF}" type="slidenum">
               <a:rPr lang="en-US" smtClean="0"/>
-              <a:t>‹#›</a:t>
+              <a:t>‹N°›</a:t>
             </a:fld>
             <a:endParaRPr lang="en-US"/>
           </a:p>
@@ -566,10 +578,9 @@
           <a:lstStyle/>
           <a:p>
             <a:r>
-              <a:rPr lang="en-US" smtClean="0"/>
+              <a:rPr lang="en-US"/>
               <a:t>Click to edit Master title style</a:t>
             </a:r>
-            <a:endParaRPr lang="en-US"/>
           </a:p>
         </p:txBody>
       </p:sp>
@@ -595,38 +606,37 @@
           <a:p>
             <a:pPr lvl="0"/>
             <a:r>
-              <a:rPr lang="en-US" smtClean="0"/>
+              <a:rPr lang="en-US"/>
               <a:t>Click to edit Master text styles</a:t>
             </a:r>
           </a:p>
           <a:p>
             <a:pPr lvl="1"/>
             <a:r>
-              <a:rPr lang="en-US" smtClean="0"/>
+              <a:rPr lang="en-US"/>
               <a:t>Second level</a:t>
             </a:r>
           </a:p>
           <a:p>
             <a:pPr lvl="2"/>
             <a:r>
-              <a:rPr lang="en-US" smtClean="0"/>
+              <a:rPr lang="en-US"/>
               <a:t>Third level</a:t>
             </a:r>
           </a:p>
           <a:p>
             <a:pPr lvl="3"/>
             <a:r>
-              <a:rPr lang="en-US" smtClean="0"/>
+              <a:rPr lang="en-US"/>
               <a:t>Fourth level</a:t>
             </a:r>
           </a:p>
           <a:p>
             <a:pPr lvl="4"/>
             <a:r>
-              <a:rPr lang="en-US" smtClean="0"/>
+              <a:rPr lang="en-US"/>
               <a:t>Fifth level</a:t>
             </a:r>
-            <a:endParaRPr lang="en-US"/>
           </a:p>
         </p:txBody>
       </p:sp>
@@ -647,7 +657,7 @@
           <a:p>
             <a:fld id="{5BCAD085-E8A6-8845-BD4E-CB4CCA059FC4}" type="datetimeFigureOut">
               <a:rPr lang="en-US" smtClean="0"/>
-              <a:t>1/27/13</a:t>
+              <a:t>6/8/26</a:t>
             </a:fld>
             <a:endParaRPr lang="en-US"/>
           </a:p>
@@ -689,7 +699,7 @@
           <a:p>
             <a:fld id="{C1FF6DA9-008F-8B48-92A6-B652298478BF}" type="slidenum">
               <a:rPr lang="en-US" smtClean="0"/>
-              <a:t>‹#›</a:t>
+              <a:t>‹N°›</a:t>
             </a:fld>
             <a:endParaRPr lang="en-US"/>
           </a:p>
@@ -741,10 +751,9 @@
           <a:lstStyle/>
           <a:p>
             <a:r>
-              <a:rPr lang="en-US" smtClean="0"/>
+              <a:rPr lang="en-US"/>
               <a:t>Click to edit Master title style</a:t>
             </a:r>
-            <a:endParaRPr lang="en-US"/>
           </a:p>
         </p:txBody>
       </p:sp>
@@ -765,38 +774,37 @@
           <a:p>
             <a:pPr lvl="0"/>
             <a:r>
-              <a:rPr lang="en-US" smtClean="0"/>
+              <a:rPr lang="en-US"/>
               <a:t>Click to edit Master text styles</a:t>
             </a:r>
           </a:p>
           <a:p>
             <a:pPr lvl="1"/>
             <a:r>
-              <a:rPr lang="en-US" smtClean="0"/>
+              <a:rPr lang="en-US"/>
               <a:t>Second level</a:t>
             </a:r>
           </a:p>
           <a:p>
             <a:pPr lvl="2"/>
             <a:r>
-              <a:rPr lang="en-US" smtClean="0"/>
+              <a:rPr lang="en-US"/>
               <a:t>Third level</a:t>
             </a:r>
           </a:p>
           <a:p>
             <a:pPr lvl="3"/>
             <a:r>
-              <a:rPr lang="en-US" smtClean="0"/>
+              <a:rPr lang="en-US"/>
               <a:t>Fourth level</a:t>
             </a:r>
           </a:p>
           <a:p>
             <a:pPr lvl="4"/>
             <a:r>
-              <a:rPr lang="en-US" smtClean="0"/>
+              <a:rPr lang="en-US"/>
               <a:t>Fifth level</a:t>
             </a:r>
-            <a:endParaRPr lang="en-US"/>
           </a:p>
         </p:txBody>
       </p:sp>
@@ -817,7 +825,7 @@
           <a:p>
             <a:fld id="{5BCAD085-E8A6-8845-BD4E-CB4CCA059FC4}" type="datetimeFigureOut">
               <a:rPr lang="en-US" smtClean="0"/>
-              <a:t>1/27/13</a:t>
+              <a:t>6/8/26</a:t>
             </a:fld>
             <a:endParaRPr lang="en-US"/>
           </a:p>
@@ -859,7 +867,7 @@
           <a:p>
             <a:fld id="{C1FF6DA9-008F-8B48-92A6-B652298478BF}" type="slidenum">
               <a:rPr lang="en-US" smtClean="0"/>
-              <a:t>‹#›</a:t>
+              <a:t>‹N°›</a:t>
             </a:fld>
             <a:endParaRPr lang="en-US"/>
           </a:p>
@@ -920,10 +928,9 @@
           </a:lstStyle>
           <a:p>
             <a:r>
-              <a:rPr lang="en-US" smtClean="0"/>
+              <a:rPr lang="en-US"/>
               <a:t>Click to edit Master title style</a:t>
             </a:r>
-            <a:endParaRPr lang="en-US"/>
           </a:p>
         </p:txBody>
       </p:sp>
@@ -1040,7 +1047,7 @@
           <a:p>
             <a:pPr lvl="0"/>
             <a:r>
-              <a:rPr lang="en-US" smtClean="0"/>
+              <a:rPr lang="en-US"/>
               <a:t>Click to edit Master text styles</a:t>
             </a:r>
           </a:p>
@@ -1063,7 +1070,7 @@
           <a:p>
             <a:fld id="{5BCAD085-E8A6-8845-BD4E-CB4CCA059FC4}" type="datetimeFigureOut">
               <a:rPr lang="en-US" smtClean="0"/>
-              <a:t>1/27/13</a:t>
+              <a:t>6/8/26</a:t>
             </a:fld>
             <a:endParaRPr lang="en-US"/>
           </a:p>
@@ -1105,7 +1112,7 @@
           <a:p>
             <a:fld id="{C1FF6DA9-008F-8B48-92A6-B652298478BF}" type="slidenum">
               <a:rPr lang="en-US" smtClean="0"/>
-              <a:t>‹#›</a:t>
+              <a:t>‹N°›</a:t>
             </a:fld>
             <a:endParaRPr lang="en-US"/>
           </a:p>
@@ -1157,10 +1164,9 @@
           <a:lstStyle/>
           <a:p>
             <a:r>
-              <a:rPr lang="en-US" smtClean="0"/>
+              <a:rPr lang="en-US"/>
               <a:t>Click to edit Master title style</a:t>
             </a:r>
-            <a:endParaRPr lang="en-US"/>
           </a:p>
         </p:txBody>
       </p:sp>
@@ -1214,38 +1220,37 @@
           <a:p>
             <a:pPr lvl="0"/>
             <a:r>
-              <a:rPr lang="en-US" smtClean="0"/>
+              <a:rPr lang="en-US"/>
               <a:t>Click to edit Master text styles</a:t>
             </a:r>
           </a:p>
           <a:p>
             <a:pPr lvl="1"/>
             <a:r>
-              <a:rPr lang="en-US" smtClean="0"/>
+              <a:rPr lang="en-US"/>
               <a:t>Second level</a:t>
             </a:r>
           </a:p>
           <a:p>
             <a:pPr lvl="2"/>
             <a:r>
-              <a:rPr lang="en-US" smtClean="0"/>
+              <a:rPr lang="en-US"/>
               <a:t>Third level</a:t>
             </a:r>
           </a:p>
           <a:p>
             <a:pPr lvl="3"/>
             <a:r>
-              <a:rPr lang="en-US" smtClean="0"/>
+              <a:rPr lang="en-US"/>
               <a:t>Fourth level</a:t>
             </a:r>
           </a:p>
           <a:p>
             <a:pPr lvl="4"/>
             <a:r>
-              <a:rPr lang="en-US" smtClean="0"/>
+              <a:rPr lang="en-US"/>
               <a:t>Fifth level</a:t>
             </a:r>
-            <a:endParaRPr lang="en-US"/>
           </a:p>
         </p:txBody>
       </p:sp>
@@ -1299,38 +1304,37 @@
           <a:p>
             <a:pPr lvl="0"/>
             <a:r>
-              <a:rPr lang="en-US" smtClean="0"/>
+              <a:rPr lang="en-US"/>
               <a:t>Click to edit Master text styles</a:t>
             </a:r>
           </a:p>
           <a:p>
             <a:pPr lvl="1"/>
             <a:r>
-              <a:rPr lang="en-US" smtClean="0"/>
+              <a:rPr lang="en-US"/>
               <a:t>Second level</a:t>
             </a:r>
           </a:p>
           <a:p>
             <a:pPr lvl="2"/>
             <a:r>
-              <a:rPr lang="en-US" smtClean="0"/>
+              <a:rPr lang="en-US"/>
               <a:t>Third level</a:t>
             </a:r>
           </a:p>
           <a:p>
             <a:pPr lvl="3"/>
             <a:r>
-              <a:rPr lang="en-US" smtClean="0"/>
+              <a:rPr lang="en-US"/>
               <a:t>Fourth level</a:t>
             </a:r>
           </a:p>
           <a:p>
             <a:pPr lvl="4"/>
             <a:r>
-              <a:rPr lang="en-US" smtClean="0"/>
+              <a:rPr lang="en-US"/>
               <a:t>Fifth level</a:t>
             </a:r>
-            <a:endParaRPr lang="en-US"/>
           </a:p>
         </p:txBody>
       </p:sp>
@@ -1351,7 +1355,7 @@
           <a:p>
             <a:fld id="{5BCAD085-E8A6-8845-BD4E-CB4CCA059FC4}" type="datetimeFigureOut">
               <a:rPr lang="en-US" smtClean="0"/>
-              <a:t>1/27/13</a:t>
+              <a:t>6/8/26</a:t>
             </a:fld>
             <a:endParaRPr lang="en-US"/>
           </a:p>
@@ -1393,7 +1397,7 @@
           <a:p>
             <a:fld id="{C1FF6DA9-008F-8B48-92A6-B652298478BF}" type="slidenum">
               <a:rPr lang="en-US" smtClean="0"/>
-              <a:t>‹#›</a:t>
+              <a:t>‹N°›</a:t>
             </a:fld>
             <a:endParaRPr lang="en-US"/>
           </a:p>
@@ -1449,10 +1453,9 @@
           </a:lstStyle>
           <a:p>
             <a:r>
-              <a:rPr lang="en-US" smtClean="0"/>
+              <a:rPr lang="en-US"/>
               <a:t>Click to edit Master title style</a:t>
             </a:r>
-            <a:endParaRPr lang="en-US"/>
           </a:p>
         </p:txBody>
       </p:sp>
@@ -1515,7 +1518,7 @@
           <a:p>
             <a:pPr lvl="0"/>
             <a:r>
-              <a:rPr lang="en-US" smtClean="0"/>
+              <a:rPr lang="en-US"/>
               <a:t>Click to edit Master text styles</a:t>
             </a:r>
           </a:p>
@@ -1571,38 +1574,37 @@
           <a:p>
             <a:pPr lvl="0"/>
             <a:r>
-              <a:rPr lang="en-US" smtClean="0"/>
+              <a:rPr lang="en-US"/>
               <a:t>Click to edit Master text styles</a:t>
             </a:r>
           </a:p>
           <a:p>
             <a:pPr lvl="1"/>
             <a:r>
-              <a:rPr lang="en-US" smtClean="0"/>
+              <a:rPr lang="en-US"/>
               <a:t>Second level</a:t>
             </a:r>
           </a:p>
           <a:p>
             <a:pPr lvl="2"/>
             <a:r>
-              <a:rPr lang="en-US" smtClean="0"/>
+              <a:rPr lang="en-US"/>
               <a:t>Third level</a:t>
             </a:r>
           </a:p>
           <a:p>
             <a:pPr lvl="3"/>
             <a:r>
-              <a:rPr lang="en-US" smtClean="0"/>
+              <a:rPr lang="en-US"/>
               <a:t>Fourth level</a:t>
             </a:r>
           </a:p>
           <a:p>
             <a:pPr lvl="4"/>
             <a:r>
-              <a:rPr lang="en-US" smtClean="0"/>
+              <a:rPr lang="en-US"/>
               <a:t>Fifth level</a:t>
             </a:r>
-            <a:endParaRPr lang="en-US"/>
           </a:p>
         </p:txBody>
       </p:sp>
@@ -1665,7 +1667,7 @@
           <a:p>
             <a:pPr lvl="0"/>
             <a:r>
-              <a:rPr lang="en-US" smtClean="0"/>
+              <a:rPr lang="en-US"/>
               <a:t>Click to edit Master text styles</a:t>
             </a:r>
           </a:p>
@@ -1721,38 +1723,37 @@
           <a:p>
             <a:pPr lvl="0"/>
             <a:r>
-              <a:rPr lang="en-US" smtClean="0"/>
+              <a:rPr lang="en-US"/>
               <a:t>Click to edit Master text styles</a:t>
             </a:r>
           </a:p>
           <a:p>
             <a:pPr lvl="1"/>
             <a:r>
-              <a:rPr lang="en-US" smtClean="0"/>
+              <a:rPr lang="en-US"/>
               <a:t>Second level</a:t>
             </a:r>
           </a:p>
           <a:p>
             <a:pPr lvl="2"/>
             <a:r>
-              <a:rPr lang="en-US" smtClean="0"/>
+              <a:rPr lang="en-US"/>
               <a:t>Third level</a:t>
             </a:r>
           </a:p>
           <a:p>
             <a:pPr lvl="3"/>
             <a:r>
-              <a:rPr lang="en-US" smtClean="0"/>
+              <a:rPr lang="en-US"/>
               <a:t>Fourth level</a:t>
             </a:r>
           </a:p>
           <a:p>
             <a:pPr lvl="4"/>
             <a:r>
-              <a:rPr lang="en-US" smtClean="0"/>
+              <a:rPr lang="en-US"/>
               <a:t>Fifth level</a:t>
             </a:r>
-            <a:endParaRPr lang="en-US"/>
           </a:p>
         </p:txBody>
       </p:sp>
@@ -1773,7 +1774,7 @@
           <a:p>
             <a:fld id="{5BCAD085-E8A6-8845-BD4E-CB4CCA059FC4}" type="datetimeFigureOut">
               <a:rPr lang="en-US" smtClean="0"/>
-              <a:t>1/27/13</a:t>
+              <a:t>6/8/26</a:t>
             </a:fld>
             <a:endParaRPr lang="en-US"/>
           </a:p>
@@ -1815,7 +1816,7 @@
           <a:p>
             <a:fld id="{C1FF6DA9-008F-8B48-92A6-B652298478BF}" type="slidenum">
               <a:rPr lang="en-US" smtClean="0"/>
-              <a:t>‹#›</a:t>
+              <a:t>‹N°›</a:t>
             </a:fld>
             <a:endParaRPr lang="en-US"/>
           </a:p>
@@ -1867,10 +1868,9 @@
           <a:lstStyle/>
           <a:p>
             <a:r>
-              <a:rPr lang="en-US" smtClean="0"/>
+              <a:rPr lang="en-US"/>
               <a:t>Click to edit Master title style</a:t>
             </a:r>
-            <a:endParaRPr lang="en-US"/>
           </a:p>
         </p:txBody>
       </p:sp>
@@ -1891,7 +1891,7 @@
           <a:p>
             <a:fld id="{5BCAD085-E8A6-8845-BD4E-CB4CCA059FC4}" type="datetimeFigureOut">
               <a:rPr lang="en-US" smtClean="0"/>
-              <a:t>1/27/13</a:t>
+              <a:t>6/8/26</a:t>
             </a:fld>
             <a:endParaRPr lang="en-US"/>
           </a:p>
@@ -1933,7 +1933,7 @@
           <a:p>
             <a:fld id="{C1FF6DA9-008F-8B48-92A6-B652298478BF}" type="slidenum">
               <a:rPr lang="en-US" smtClean="0"/>
-              <a:t>‹#›</a:t>
+              <a:t>‹N°›</a:t>
             </a:fld>
             <a:endParaRPr lang="en-US"/>
           </a:p>
@@ -1986,7 +1986,7 @@
           <a:p>
             <a:fld id="{5BCAD085-E8A6-8845-BD4E-CB4CCA059FC4}" type="datetimeFigureOut">
               <a:rPr lang="en-US" smtClean="0"/>
-              <a:t>1/27/13</a:t>
+              <a:t>6/8/26</a:t>
             </a:fld>
             <a:endParaRPr lang="en-US"/>
           </a:p>
@@ -2028,7 +2028,7 @@
           <a:p>
             <a:fld id="{C1FF6DA9-008F-8B48-92A6-B652298478BF}" type="slidenum">
               <a:rPr lang="en-US" smtClean="0"/>
-              <a:t>‹#›</a:t>
+              <a:t>‹N°›</a:t>
             </a:fld>
             <a:endParaRPr lang="en-US"/>
           </a:p>
@@ -2089,10 +2089,9 @@
           </a:lstStyle>
           <a:p>
             <a:r>
-              <a:rPr lang="en-US" smtClean="0"/>
+              <a:rPr lang="en-US"/>
               <a:t>Click to edit Master title style</a:t>
             </a:r>
-            <a:endParaRPr lang="en-US"/>
           </a:p>
         </p:txBody>
       </p:sp>
@@ -2146,38 +2145,37 @@
           <a:p>
             <a:pPr lvl="0"/>
             <a:r>
-              <a:rPr lang="en-US" smtClean="0"/>
+              <a:rPr lang="en-US"/>
               <a:t>Click to edit Master text styles</a:t>
             </a:r>
           </a:p>
           <a:p>
             <a:pPr lvl="1"/>
             <a:r>
-              <a:rPr lang="en-US" smtClean="0"/>
+              <a:rPr lang="en-US"/>
               <a:t>Second level</a:t>
             </a:r>
           </a:p>
           <a:p>
             <a:pPr lvl="2"/>
             <a:r>
-              <a:rPr lang="en-US" smtClean="0"/>
+              <a:rPr lang="en-US"/>
               <a:t>Third level</a:t>
             </a:r>
           </a:p>
           <a:p>
             <a:pPr lvl="3"/>
             <a:r>
-              <a:rPr lang="en-US" smtClean="0"/>
+              <a:rPr lang="en-US"/>
               <a:t>Fourth level</a:t>
             </a:r>
           </a:p>
           <a:p>
             <a:pPr lvl="4"/>
             <a:r>
-              <a:rPr lang="en-US" smtClean="0"/>
+              <a:rPr lang="en-US"/>
               <a:t>Fifth level</a:t>
             </a:r>
-            <a:endParaRPr lang="en-US"/>
           </a:p>
         </p:txBody>
       </p:sp>
@@ -2240,7 +2238,7 @@
           <a:p>
             <a:pPr lvl="0"/>
             <a:r>
-              <a:rPr lang="en-US" smtClean="0"/>
+              <a:rPr lang="en-US"/>
               <a:t>Click to edit Master text styles</a:t>
             </a:r>
           </a:p>
@@ -2263,7 +2261,7 @@
           <a:p>
             <a:fld id="{5BCAD085-E8A6-8845-BD4E-CB4CCA059FC4}" type="datetimeFigureOut">
               <a:rPr lang="en-US" smtClean="0"/>
-              <a:t>1/27/13</a:t>
+              <a:t>6/8/26</a:t>
             </a:fld>
             <a:endParaRPr lang="en-US"/>
           </a:p>
@@ -2305,7 +2303,7 @@
           <a:p>
             <a:fld id="{C1FF6DA9-008F-8B48-92A6-B652298478BF}" type="slidenum">
               <a:rPr lang="en-US" smtClean="0"/>
-              <a:t>‹#›</a:t>
+              <a:t>‹N°›</a:t>
             </a:fld>
             <a:endParaRPr lang="en-US"/>
           </a:p>
@@ -2366,10 +2364,9 @@
           </a:lstStyle>
           <a:p>
             <a:r>
-              <a:rPr lang="en-US" smtClean="0"/>
+              <a:rPr lang="en-US"/>
               <a:t>Click to edit Master title style</a:t>
             </a:r>
-            <a:endParaRPr lang="en-US"/>
           </a:p>
         </p:txBody>
       </p:sp>
@@ -2493,7 +2490,7 @@
           <a:p>
             <a:pPr lvl="0"/>
             <a:r>
-              <a:rPr lang="en-US" smtClean="0"/>
+              <a:rPr lang="en-US"/>
               <a:t>Click to edit Master text styles</a:t>
             </a:r>
           </a:p>
@@ -2516,7 +2513,7 @@
           <a:p>
             <a:fld id="{5BCAD085-E8A6-8845-BD4E-CB4CCA059FC4}" type="datetimeFigureOut">
               <a:rPr lang="en-US" smtClean="0"/>
-              <a:t>1/27/13</a:t>
+              <a:t>6/8/26</a:t>
             </a:fld>
             <a:endParaRPr lang="en-US"/>
           </a:p>
@@ -2558,7 +2555,7 @@
           <a:p>
             <a:fld id="{C1FF6DA9-008F-8B48-92A6-B652298478BF}" type="slidenum">
               <a:rPr lang="en-US" smtClean="0"/>
-              <a:t>‹#›</a:t>
+              <a:t>‹N°›</a:t>
             </a:fld>
             <a:endParaRPr lang="en-US"/>
           </a:p>
@@ -2625,10 +2622,9 @@
           <a:lstStyle/>
           <a:p>
             <a:r>
-              <a:rPr lang="en-US" smtClean="0"/>
+              <a:rPr lang="en-US"/>
               <a:t>Click to edit Master title style</a:t>
             </a:r>
-            <a:endParaRPr lang="en-US"/>
           </a:p>
         </p:txBody>
       </p:sp>
@@ -2659,38 +2655,37 @@
           <a:p>
             <a:pPr lvl="0"/>
             <a:r>
-              <a:rPr lang="en-US" smtClean="0"/>
+              <a:rPr lang="en-US"/>
               <a:t>Click to edit Master text styles</a:t>
             </a:r>
           </a:p>
           <a:p>
             <a:pPr lvl="1"/>
             <a:r>
-              <a:rPr lang="en-US" smtClean="0"/>
+              <a:rPr lang="en-US"/>
               <a:t>Second level</a:t>
             </a:r>
           </a:p>
           <a:p>
             <a:pPr lvl="2"/>
             <a:r>
-              <a:rPr lang="en-US" smtClean="0"/>
+              <a:rPr lang="en-US"/>
               <a:t>Third level</a:t>
             </a:r>
           </a:p>
           <a:p>
             <a:pPr lvl="3"/>
             <a:r>
-              <a:rPr lang="en-US" smtClean="0"/>
+              <a:rPr lang="en-US"/>
               <a:t>Fourth level</a:t>
             </a:r>
           </a:p>
           <a:p>
             <a:pPr lvl="4"/>
             <a:r>
-              <a:rPr lang="en-US" smtClean="0"/>
+              <a:rPr lang="en-US"/>
               <a:t>Fifth level</a:t>
             </a:r>
-            <a:endParaRPr lang="en-US"/>
           </a:p>
         </p:txBody>
       </p:sp>
@@ -2729,7 +2724,7 @@
           <a:p>
             <a:fld id="{5BCAD085-E8A6-8845-BD4E-CB4CCA059FC4}" type="datetimeFigureOut">
               <a:rPr lang="en-US" smtClean="0"/>
-              <a:t>1/27/13</a:t>
+              <a:t>6/8/26</a:t>
             </a:fld>
             <a:endParaRPr lang="en-US"/>
           </a:p>
@@ -2807,7 +2802,7 @@
           <a:p>
             <a:fld id="{C1FF6DA9-008F-8B48-92A6-B652298478BF}" type="slidenum">
               <a:rPr lang="en-US" smtClean="0"/>
-              <a:t>‹#›</a:t>
+              <a:t>‹N°›</a:t>
             </a:fld>
             <a:endParaRPr lang="en-US"/>
           </a:p>
@@ -3088,7 +3083,7 @@
 </file>
 
 <file path=ppt/slides/slide1.xml><?xml version="1.0" encoding="utf-8"?>
-<p:sld xmlns:a="http://schemas.openxmlformats.org/drawingml/2006/main" xmlns:p="http://schemas.openxmlformats.org/presentationml/2006/main" xmlns:r="http://schemas.openxmlformats.org/officeDocument/2006/relationships">
+<p:sld xmlns:a="http://schemas.openxmlformats.org/drawingml/2006/main" xmlns:r="http://schemas.openxmlformats.org/officeDocument/2006/relationships" xmlns:p="http://schemas.openxmlformats.org/presentationml/2006/main">
   <p:cSld>
     <p:bg>
       <p:bgPr>
@@ -3104,7 +3099,14 @@
         <p:cNvGrpSpPr/>
         <p:nvPr/>
       </p:nvGrpSpPr>
-      <p:grpSpPr/>
+      <p:grpSpPr>
+        <a:xfrm>
+          <a:off x="0" y="0"/>
+          <a:ext cx="0" cy="0"/>
+          <a:chOff x="0" y="0"/>
+          <a:chExt cx="0" cy="0"/>
+        </a:xfrm>
+      </p:grpSpPr>
       <p:sp>
         <p:nvSpPr>
           <p:cNvPr id="2" name="TextBox 1"/>
@@ -3182,7 +3184,7 @@
         <p:spPr>
           <a:xfrm>
             <a:off x="914400" y="3474720"/>
-            <a:ext cx="10362895" cy="2286000"/>
+            <a:ext cx="10362895" cy="1000274"/>
           </a:xfrm>
           <a:prstGeom prst="rect">
             <a:avLst/>
@@ -3207,14 +3209,45 @@
               </a:defRPr>
             </a:pPr>
             <a:r>
-              <a:t>Student: Milan LOI | BUT Informatique (Parcours Réalisation d'applications)</a:t>
-            </a:r>
-            <a:br/>
-            <a:r>
+              <a:rPr dirty="0"/>
+              <a:t>Student: Milan LOI | BUT Informatique (</a:t>
+            </a:r>
+            <a:r>
+              <a:rPr dirty="0" err="1"/>
+              <a:t>Parcours</a:t>
+            </a:r>
+            <a:r>
+              <a:rPr dirty="0"/>
+              <a:t> </a:t>
+            </a:r>
+            <a:r>
+              <a:rPr dirty="0" err="1"/>
+              <a:t>Réalisation</a:t>
+            </a:r>
+            <a:r>
+              <a:rPr dirty="0"/>
+              <a:t> </a:t>
+            </a:r>
+            <a:r>
+              <a:rPr dirty="0" err="1"/>
+              <a:t>d'applications</a:t>
+            </a:r>
+            <a:r>
+              <a:rPr dirty="0"/>
+              <a:t>)</a:t>
+            </a:r>
+            <a:br>
+              <a:rPr dirty="0"/>
+            </a:br>
+            <a:r>
+              <a:rPr dirty="0"/>
               <a:t>University: Université de Limoges - IUT de Limoges, Département Informatique</a:t>
             </a:r>
-            <a:br/>
-            <a:r>
+            <a:br>
+              <a:rPr dirty="0"/>
+            </a:br>
+            <a:r>
+              <a:rPr dirty="0"/>
               <a:t>Host Institution: Robert Gordon University (RGU), School of Computing Science and Digital Media</a:t>
             </a:r>
           </a:p>
@@ -3228,11 +3261,42 @@
               </a:defRPr>
             </a:pPr>
             <a:r>
-              <a:t>Host Supervisor: Dr. Shahana Bano (RGU) | Academic Advisor: M. Jean-Marc Garcia (IUT de Limoges)</a:t>
-            </a:r>
-            <a:br/>
-            <a:r>
-              <a:t>Internship Period: April 6, 2026 – June 12, 2026 (10 Weeks)</a:t>
+              <a:rPr dirty="0"/>
+              <a:t>Host Supervisor: Dr. Shahana Bano (RGU) | Academic Advisor: M. </a:t>
+            </a:r>
+            <a:r>
+              <a:rPr lang="fr-FR"/>
+              <a:t>Jonathan Paris </a:t>
+            </a:r>
+            <a:r>
+              <a:t>(</a:t>
+            </a:r>
+            <a:r>
+              <a:rPr dirty="0"/>
+              <a:t>IUT de Limoges)</a:t>
+            </a:r>
+            <a:br>
+              <a:rPr dirty="0"/>
+            </a:br>
+            <a:r>
+              <a:rPr dirty="0"/>
+              <a:t>Internship Period: April </a:t>
+            </a:r>
+            <a:r>
+              <a:rPr lang="fr-FR" dirty="0"/>
+              <a:t>13</a:t>
+            </a:r>
+            <a:r>
+              <a:rPr dirty="0"/>
+              <a:t>, 2026 – June 1</a:t>
+            </a:r>
+            <a:r>
+              <a:rPr lang="fr-FR" dirty="0"/>
+              <a:t>9</a:t>
+            </a:r>
+            <a:r>
+              <a:rPr dirty="0"/>
+              <a:t>, 2026 (10 Weeks)</a:t>
             </a:r>
           </a:p>
         </p:txBody>
@@ -3282,7 +3346,7 @@
 </file>
 
 <file path=ppt/slides/slide10.xml><?xml version="1.0" encoding="utf-8"?>
-<p:sld xmlns:a="http://schemas.openxmlformats.org/drawingml/2006/main" xmlns:p="http://schemas.openxmlformats.org/presentationml/2006/main" xmlns:r="http://schemas.openxmlformats.org/officeDocument/2006/relationships">
+<p:sld xmlns:a="http://schemas.openxmlformats.org/drawingml/2006/main" xmlns:r="http://schemas.openxmlformats.org/officeDocument/2006/relationships" xmlns:p="http://schemas.openxmlformats.org/presentationml/2006/main">
   <p:cSld>
     <p:bg>
       <p:bgPr>
@@ -3298,7 +3362,14 @@
         <p:cNvGrpSpPr/>
         <p:nvPr/>
       </p:nvGrpSpPr>
-      <p:grpSpPr/>
+      <p:grpSpPr>
+        <a:xfrm>
+          <a:off x="0" y="0"/>
+          <a:ext cx="0" cy="0"/>
+          <a:chOff x="0" y="0"/>
+          <a:chExt cx="0" cy="0"/>
+        </a:xfrm>
+      </p:grpSpPr>
       <p:sp>
         <p:nvSpPr>
           <p:cNvPr id="2" name="TextBox 1"/>
@@ -3377,6 +3448,7 @@
           <a:lstStyle/>
           <a:p>
             <a:pPr algn="ctr"/>
+            <a:endParaRPr/>
           </a:p>
         </p:txBody>
       </p:sp>
@@ -3597,6 +3669,7 @@
           <a:lstStyle/>
           <a:p>
             <a:pPr algn="ctr"/>
+            <a:endParaRPr/>
           </a:p>
         </p:txBody>
       </p:sp>
@@ -3723,7 +3796,7 @@
 </file>
 
 <file path=ppt/slides/slide2.xml><?xml version="1.0" encoding="utf-8"?>
-<p:sld xmlns:a="http://schemas.openxmlformats.org/drawingml/2006/main" xmlns:p="http://schemas.openxmlformats.org/presentationml/2006/main" xmlns:r="http://schemas.openxmlformats.org/officeDocument/2006/relationships">
+<p:sld xmlns:a="http://schemas.openxmlformats.org/drawingml/2006/main" xmlns:r="http://schemas.openxmlformats.org/officeDocument/2006/relationships" xmlns:p="http://schemas.openxmlformats.org/presentationml/2006/main">
   <p:cSld>
     <p:bg>
       <p:bgPr>
@@ -3739,7 +3812,14 @@
         <p:cNvGrpSpPr/>
         <p:nvPr/>
       </p:nvGrpSpPr>
-      <p:grpSpPr/>
+      <p:grpSpPr>
+        <a:xfrm>
+          <a:off x="0" y="0"/>
+          <a:ext cx="0" cy="0"/>
+          <a:chOff x="0" y="0"/>
+          <a:chExt cx="0" cy="0"/>
+        </a:xfrm>
+      </p:grpSpPr>
       <p:sp>
         <p:nvSpPr>
           <p:cNvPr id="2" name="TextBox 1"/>
@@ -3818,6 +3898,7 @@
           <a:lstStyle/>
           <a:p>
             <a:pPr algn="ctr"/>
+            <a:endParaRPr/>
           </a:p>
         </p:txBody>
       </p:sp>
@@ -4038,6 +4119,7 @@
           <a:lstStyle/>
           <a:p>
             <a:pPr algn="ctr"/>
+            <a:endParaRPr/>
           </a:p>
         </p:txBody>
       </p:sp>
@@ -4214,7 +4296,7 @@
 </file>
 
 <file path=ppt/slides/slide3.xml><?xml version="1.0" encoding="utf-8"?>
-<p:sld xmlns:a="http://schemas.openxmlformats.org/drawingml/2006/main" xmlns:p="http://schemas.openxmlformats.org/presentationml/2006/main" xmlns:r="http://schemas.openxmlformats.org/officeDocument/2006/relationships">
+<p:sld xmlns:a="http://schemas.openxmlformats.org/drawingml/2006/main" xmlns:r="http://schemas.openxmlformats.org/officeDocument/2006/relationships" xmlns:p="http://schemas.openxmlformats.org/presentationml/2006/main">
   <p:cSld>
     <p:bg>
       <p:bgPr>
@@ -4230,7 +4312,14 @@
         <p:cNvGrpSpPr/>
         <p:nvPr/>
       </p:nvGrpSpPr>
-      <p:grpSpPr/>
+      <p:grpSpPr>
+        <a:xfrm>
+          <a:off x="0" y="0"/>
+          <a:ext cx="0" cy="0"/>
+          <a:chOff x="0" y="0"/>
+          <a:chExt cx="0" cy="0"/>
+        </a:xfrm>
+      </p:grpSpPr>
       <p:sp>
         <p:nvSpPr>
           <p:cNvPr id="2" name="TextBox 1"/>
@@ -4309,6 +4398,7 @@
           <a:lstStyle/>
           <a:p>
             <a:pPr algn="ctr"/>
+            <a:endParaRPr/>
           </a:p>
         </p:txBody>
       </p:sp>
@@ -4504,6 +4594,7 @@
           <a:lstStyle/>
           <a:p>
             <a:pPr algn="ctr"/>
+            <a:endParaRPr/>
           </a:p>
         </p:txBody>
       </p:sp>
@@ -4546,7 +4637,7 @@
           </a:p>
           <a:p>
             <a:pPr algn="ctr">
-              <a:defRPr sz="1400" i="1" b="1">
+              <a:defRPr sz="1400" b="1" i="1">
                 <a:solidFill>
                   <a:srgbClr val="1F2937"/>
                 </a:solidFill>
@@ -4568,7 +4659,7 @@
 </file>
 
 <file path=ppt/slides/slide4.xml><?xml version="1.0" encoding="utf-8"?>
-<p:sld xmlns:a="http://schemas.openxmlformats.org/drawingml/2006/main" xmlns:p="http://schemas.openxmlformats.org/presentationml/2006/main" xmlns:r="http://schemas.openxmlformats.org/officeDocument/2006/relationships">
+<p:sld xmlns:a="http://schemas.openxmlformats.org/drawingml/2006/main" xmlns:r="http://schemas.openxmlformats.org/officeDocument/2006/relationships" xmlns:p="http://schemas.openxmlformats.org/presentationml/2006/main">
   <p:cSld>
     <p:bg>
       <p:bgPr>
@@ -4584,7 +4675,14 @@
         <p:cNvGrpSpPr/>
         <p:nvPr/>
       </p:nvGrpSpPr>
-      <p:grpSpPr/>
+      <p:grpSpPr>
+        <a:xfrm>
+          <a:off x="0" y="0"/>
+          <a:ext cx="0" cy="0"/>
+          <a:chOff x="0" y="0"/>
+          <a:chExt cx="0" cy="0"/>
+        </a:xfrm>
+      </p:grpSpPr>
       <p:sp>
         <p:nvSpPr>
           <p:cNvPr id="2" name="TextBox 1"/>
@@ -4663,6 +4761,7 @@
           <a:lstStyle/>
           <a:p>
             <a:pPr algn="ctr"/>
+            <a:endParaRPr/>
           </a:p>
         </p:txBody>
       </p:sp>
@@ -4858,6 +4957,7 @@
           <a:lstStyle/>
           <a:p>
             <a:pPr algn="ctr"/>
+            <a:endParaRPr/>
           </a:p>
         </p:txBody>
       </p:sp>
@@ -4984,7 +5084,7 @@
 </file>
 
 <file path=ppt/slides/slide5.xml><?xml version="1.0" encoding="utf-8"?>
-<p:sld xmlns:a="http://schemas.openxmlformats.org/drawingml/2006/main" xmlns:p="http://schemas.openxmlformats.org/presentationml/2006/main" xmlns:r="http://schemas.openxmlformats.org/officeDocument/2006/relationships">
+<p:sld xmlns:a="http://schemas.openxmlformats.org/drawingml/2006/main" xmlns:r="http://schemas.openxmlformats.org/officeDocument/2006/relationships" xmlns:p="http://schemas.openxmlformats.org/presentationml/2006/main">
   <p:cSld>
     <p:bg>
       <p:bgPr>
@@ -5000,7 +5100,14 @@
         <p:cNvGrpSpPr/>
         <p:nvPr/>
       </p:nvGrpSpPr>
-      <p:grpSpPr/>
+      <p:grpSpPr>
+        <a:xfrm>
+          <a:off x="0" y="0"/>
+          <a:ext cx="0" cy="0"/>
+          <a:chOff x="0" y="0"/>
+          <a:chExt cx="0" cy="0"/>
+        </a:xfrm>
+      </p:grpSpPr>
       <p:sp>
         <p:nvSpPr>
           <p:cNvPr id="2" name="TextBox 1"/>
@@ -5079,6 +5186,7 @@
           <a:lstStyle/>
           <a:p>
             <a:pPr algn="ctr"/>
+            <a:endParaRPr/>
           </a:p>
         </p:txBody>
       </p:sp>
@@ -5274,6 +5382,7 @@
           <a:lstStyle/>
           <a:p>
             <a:pPr algn="ctr"/>
+            <a:endParaRPr/>
           </a:p>
         </p:txBody>
       </p:sp>
@@ -5335,9 +5444,27 @@
                 <a:tableStyleId>{5C22544A-7EE6-4342-B048-85BDC9FD1C3A}</a:tableStyleId>
               </a:tblPr>
               <a:tblGrid>
-                <a:gridCol w="2011680"/>
-                <a:gridCol w="1645920"/>
-                <a:gridCol w="1645920"/>
+                <a:gridCol w="2011680">
+                  <a:extLst>
+                    <a:ext uri="{9D8B030D-6E8A-4147-A177-3AD203B41FA5}">
+                      <a16:colId xmlns:a16="http://schemas.microsoft.com/office/drawing/2014/main" val="20000"/>
+                    </a:ext>
+                  </a:extLst>
+                </a:gridCol>
+                <a:gridCol w="1645920">
+                  <a:extLst>
+                    <a:ext uri="{9D8B030D-6E8A-4147-A177-3AD203B41FA5}">
+                      <a16:colId xmlns:a16="http://schemas.microsoft.com/office/drawing/2014/main" val="20001"/>
+                    </a:ext>
+                  </a:extLst>
+                </a:gridCol>
+                <a:gridCol w="1645920">
+                  <a:extLst>
+                    <a:ext uri="{9D8B030D-6E8A-4147-A177-3AD203B41FA5}">
+                      <a16:colId xmlns:a16="http://schemas.microsoft.com/office/drawing/2014/main" val="20002"/>
+                    </a:ext>
+                  </a:extLst>
+                </a:gridCol>
               </a:tblGrid>
               <a:tr h="502920">
                 <a:tc>
@@ -5412,6 +5539,11 @@
                     </a:solidFill>
                   </a:tcPr>
                 </a:tc>
+                <a:extLst>
+                  <a:ext uri="{0D108BD9-81ED-4DB2-BD59-A6C34878D82A}">
+                    <a16:rowId xmlns:a16="http://schemas.microsoft.com/office/drawing/2014/main" val="10000"/>
+                  </a:ext>
+                </a:extLst>
               </a:tr>
               <a:tr h="502920">
                 <a:tc>
@@ -5474,6 +5606,11 @@
                   </a:txBody>
                   <a:tcPr/>
                 </a:tc>
+                <a:extLst>
+                  <a:ext uri="{0D108BD9-81ED-4DB2-BD59-A6C34878D82A}">
+                    <a16:rowId xmlns:a16="http://schemas.microsoft.com/office/drawing/2014/main" val="10001"/>
+                  </a:ext>
+                </a:extLst>
               </a:tr>
               <a:tr h="502920">
                 <a:tc>
@@ -5536,6 +5673,11 @@
                   </a:txBody>
                   <a:tcPr/>
                 </a:tc>
+                <a:extLst>
+                  <a:ext uri="{0D108BD9-81ED-4DB2-BD59-A6C34878D82A}">
+                    <a16:rowId xmlns:a16="http://schemas.microsoft.com/office/drawing/2014/main" val="10002"/>
+                  </a:ext>
+                </a:extLst>
               </a:tr>
               <a:tr h="502920">
                 <a:tc>
@@ -5598,6 +5740,11 @@
                   </a:txBody>
                   <a:tcPr/>
                 </a:tc>
+                <a:extLst>
+                  <a:ext uri="{0D108BD9-81ED-4DB2-BD59-A6C34878D82A}">
+                    <a16:rowId xmlns:a16="http://schemas.microsoft.com/office/drawing/2014/main" val="10003"/>
+                  </a:ext>
+                </a:extLst>
               </a:tr>
             </a:tbl>
           </a:graphicData>
@@ -5648,7 +5795,7 @@
 </file>
 
 <file path=ppt/slides/slide6.xml><?xml version="1.0" encoding="utf-8"?>
-<p:sld xmlns:a="http://schemas.openxmlformats.org/drawingml/2006/main" xmlns:p="http://schemas.openxmlformats.org/presentationml/2006/main" xmlns:r="http://schemas.openxmlformats.org/officeDocument/2006/relationships">
+<p:sld xmlns:a="http://schemas.openxmlformats.org/drawingml/2006/main" xmlns:r="http://schemas.openxmlformats.org/officeDocument/2006/relationships" xmlns:p="http://schemas.openxmlformats.org/presentationml/2006/main">
   <p:cSld>
     <p:bg>
       <p:bgPr>
@@ -5664,7 +5811,14 @@
         <p:cNvGrpSpPr/>
         <p:nvPr/>
       </p:nvGrpSpPr>
-      <p:grpSpPr/>
+      <p:grpSpPr>
+        <a:xfrm>
+          <a:off x="0" y="0"/>
+          <a:ext cx="0" cy="0"/>
+          <a:chOff x="0" y="0"/>
+          <a:chExt cx="0" cy="0"/>
+        </a:xfrm>
+      </p:grpSpPr>
       <p:sp>
         <p:nvSpPr>
           <p:cNvPr id="2" name="TextBox 1"/>
@@ -5743,6 +5897,7 @@
           <a:lstStyle/>
           <a:p>
             <a:pPr algn="ctr"/>
+            <a:endParaRPr/>
           </a:p>
         </p:txBody>
       </p:sp>
@@ -5938,6 +6093,7 @@
           <a:lstStyle/>
           <a:p>
             <a:pPr algn="ctr"/>
+            <a:endParaRPr/>
           </a:p>
         </p:txBody>
       </p:sp>
@@ -6036,7 +6192,7 @@
 </file>
 
 <file path=ppt/slides/slide7.xml><?xml version="1.0" encoding="utf-8"?>
-<p:sld xmlns:a="http://schemas.openxmlformats.org/drawingml/2006/main" xmlns:p="http://schemas.openxmlformats.org/presentationml/2006/main" xmlns:r="http://schemas.openxmlformats.org/officeDocument/2006/relationships">
+<p:sld xmlns:a="http://schemas.openxmlformats.org/drawingml/2006/main" xmlns:r="http://schemas.openxmlformats.org/officeDocument/2006/relationships" xmlns:p="http://schemas.openxmlformats.org/presentationml/2006/main">
   <p:cSld>
     <p:bg>
       <p:bgPr>
@@ -6052,7 +6208,14 @@
         <p:cNvGrpSpPr/>
         <p:nvPr/>
       </p:nvGrpSpPr>
-      <p:grpSpPr/>
+      <p:grpSpPr>
+        <a:xfrm>
+          <a:off x="0" y="0"/>
+          <a:ext cx="0" cy="0"/>
+          <a:chOff x="0" y="0"/>
+          <a:chExt cx="0" cy="0"/>
+        </a:xfrm>
+      </p:grpSpPr>
       <p:sp>
         <p:nvSpPr>
           <p:cNvPr id="2" name="TextBox 1"/>
@@ -6131,6 +6294,7 @@
           <a:lstStyle/>
           <a:p>
             <a:pPr algn="ctr"/>
+            <a:endParaRPr/>
           </a:p>
         </p:txBody>
       </p:sp>
@@ -6326,6 +6490,7 @@
           <a:lstStyle/>
           <a:p>
             <a:pPr algn="ctr"/>
+            <a:endParaRPr/>
           </a:p>
         </p:txBody>
       </p:sp>
@@ -6441,7 +6606,7 @@
 </file>
 
 <file path=ppt/slides/slide8.xml><?xml version="1.0" encoding="utf-8"?>
-<p:sld xmlns:a="http://schemas.openxmlformats.org/drawingml/2006/main" xmlns:p="http://schemas.openxmlformats.org/presentationml/2006/main" xmlns:r="http://schemas.openxmlformats.org/officeDocument/2006/relationships">
+<p:sld xmlns:a="http://schemas.openxmlformats.org/drawingml/2006/main" xmlns:r="http://schemas.openxmlformats.org/officeDocument/2006/relationships" xmlns:p="http://schemas.openxmlformats.org/presentationml/2006/main">
   <p:cSld>
     <p:bg>
       <p:bgPr>
@@ -6457,7 +6622,14 @@
         <p:cNvGrpSpPr/>
         <p:nvPr/>
       </p:nvGrpSpPr>
-      <p:grpSpPr/>
+      <p:grpSpPr>
+        <a:xfrm>
+          <a:off x="0" y="0"/>
+          <a:ext cx="0" cy="0"/>
+          <a:chOff x="0" y="0"/>
+          <a:chExt cx="0" cy="0"/>
+        </a:xfrm>
+      </p:grpSpPr>
       <p:sp>
         <p:nvSpPr>
           <p:cNvPr id="2" name="TextBox 1"/>
@@ -6536,6 +6708,7 @@
           <a:lstStyle/>
           <a:p>
             <a:pPr algn="ctr"/>
+            <a:endParaRPr/>
           </a:p>
         </p:txBody>
       </p:sp>
@@ -6731,6 +6904,7 @@
           <a:lstStyle/>
           <a:p>
             <a:pPr algn="ctr"/>
+            <a:endParaRPr/>
           </a:p>
         </p:txBody>
       </p:sp>
@@ -6857,7 +7031,7 @@
 </file>
 
 <file path=ppt/slides/slide9.xml><?xml version="1.0" encoding="utf-8"?>
-<p:sld xmlns:a="http://schemas.openxmlformats.org/drawingml/2006/main" xmlns:p="http://schemas.openxmlformats.org/presentationml/2006/main" xmlns:r="http://schemas.openxmlformats.org/officeDocument/2006/relationships">
+<p:sld xmlns:a="http://schemas.openxmlformats.org/drawingml/2006/main" xmlns:r="http://schemas.openxmlformats.org/officeDocument/2006/relationships" xmlns:p="http://schemas.openxmlformats.org/presentationml/2006/main">
   <p:cSld>
     <p:bg>
       <p:bgPr>
@@ -6873,7 +7047,14 @@
         <p:cNvGrpSpPr/>
         <p:nvPr/>
       </p:nvGrpSpPr>
-      <p:grpSpPr/>
+      <p:grpSpPr>
+        <a:xfrm>
+          <a:off x="0" y="0"/>
+          <a:ext cx="0" cy="0"/>
+          <a:chOff x="0" y="0"/>
+          <a:chExt cx="0" cy="0"/>
+        </a:xfrm>
+      </p:grpSpPr>
       <p:sp>
         <p:nvSpPr>
           <p:cNvPr id="2" name="TextBox 1"/>
@@ -6952,6 +7133,7 @@
           <a:lstStyle/>
           <a:p>
             <a:pPr algn="ctr"/>
+            <a:endParaRPr/>
           </a:p>
         </p:txBody>
       </p:sp>
@@ -7137,11 +7319,41 @@
                 <a:tableStyleId>{5C22544A-7EE6-4342-B048-85BDC9FD1C3A}</a:tableStyleId>
               </a:tblPr>
               <a:tblGrid>
-                <a:gridCol w="2103120"/>
-                <a:gridCol w="822960"/>
-                <a:gridCol w="822960"/>
-                <a:gridCol w="822960"/>
-                <a:gridCol w="731520"/>
+                <a:gridCol w="2103120">
+                  <a:extLst>
+                    <a:ext uri="{9D8B030D-6E8A-4147-A177-3AD203B41FA5}">
+                      <a16:colId xmlns:a16="http://schemas.microsoft.com/office/drawing/2014/main" val="20000"/>
+                    </a:ext>
+                  </a:extLst>
+                </a:gridCol>
+                <a:gridCol w="822960">
+                  <a:extLst>
+                    <a:ext uri="{9D8B030D-6E8A-4147-A177-3AD203B41FA5}">
+                      <a16:colId xmlns:a16="http://schemas.microsoft.com/office/drawing/2014/main" val="20001"/>
+                    </a:ext>
+                  </a:extLst>
+                </a:gridCol>
+                <a:gridCol w="822960">
+                  <a:extLst>
+                    <a:ext uri="{9D8B030D-6E8A-4147-A177-3AD203B41FA5}">
+                      <a16:colId xmlns:a16="http://schemas.microsoft.com/office/drawing/2014/main" val="20002"/>
+                    </a:ext>
+                  </a:extLst>
+                </a:gridCol>
+                <a:gridCol w="822960">
+                  <a:extLst>
+                    <a:ext uri="{9D8B030D-6E8A-4147-A177-3AD203B41FA5}">
+                      <a16:colId xmlns:a16="http://schemas.microsoft.com/office/drawing/2014/main" val="20003"/>
+                    </a:ext>
+                  </a:extLst>
+                </a:gridCol>
+                <a:gridCol w="731520">
+                  <a:extLst>
+                    <a:ext uri="{9D8B030D-6E8A-4147-A177-3AD203B41FA5}">
+                      <a16:colId xmlns:a16="http://schemas.microsoft.com/office/drawing/2014/main" val="20004"/>
+                    </a:ext>
+                  </a:extLst>
+                </a:gridCol>
               </a:tblGrid>
               <a:tr h="335280">
                 <a:tc>
@@ -7264,6 +7476,11 @@
                     </a:solidFill>
                   </a:tcPr>
                 </a:tc>
+                <a:extLst>
+                  <a:ext uri="{0D108BD9-81ED-4DB2-BD59-A6C34878D82A}">
+                    <a16:rowId xmlns:a16="http://schemas.microsoft.com/office/drawing/2014/main" val="10000"/>
+                  </a:ext>
+                </a:extLst>
               </a:tr>
               <a:tr h="335280">
                 <a:tc>
@@ -7366,6 +7583,11 @@
                   </a:txBody>
                   <a:tcPr/>
                 </a:tc>
+                <a:extLst>
+                  <a:ext uri="{0D108BD9-81ED-4DB2-BD59-A6C34878D82A}">
+                    <a16:rowId xmlns:a16="http://schemas.microsoft.com/office/drawing/2014/main" val="10001"/>
+                  </a:ext>
+                </a:extLst>
               </a:tr>
               <a:tr h="335280">
                 <a:tc>
@@ -7468,6 +7690,11 @@
                   </a:txBody>
                   <a:tcPr/>
                 </a:tc>
+                <a:extLst>
+                  <a:ext uri="{0D108BD9-81ED-4DB2-BD59-A6C34878D82A}">
+                    <a16:rowId xmlns:a16="http://schemas.microsoft.com/office/drawing/2014/main" val="10002"/>
+                  </a:ext>
+                </a:extLst>
               </a:tr>
               <a:tr h="335280">
                 <a:tc>
@@ -7570,6 +7797,11 @@
                   </a:txBody>
                   <a:tcPr/>
                 </a:tc>
+                <a:extLst>
+                  <a:ext uri="{0D108BD9-81ED-4DB2-BD59-A6C34878D82A}">
+                    <a16:rowId xmlns:a16="http://schemas.microsoft.com/office/drawing/2014/main" val="10003"/>
+                  </a:ext>
+                </a:extLst>
               </a:tr>
               <a:tr h="335280">
                 <a:tc>
@@ -7672,6 +7904,11 @@
                   </a:txBody>
                   <a:tcPr/>
                 </a:tc>
+                <a:extLst>
+                  <a:ext uri="{0D108BD9-81ED-4DB2-BD59-A6C34878D82A}">
+                    <a16:rowId xmlns:a16="http://schemas.microsoft.com/office/drawing/2014/main" val="10004"/>
+                  </a:ext>
+                </a:extLst>
               </a:tr>
               <a:tr h="335280">
                 <a:tc>
@@ -7774,6 +8011,11 @@
                   </a:txBody>
                   <a:tcPr/>
                 </a:tc>
+                <a:extLst>
+                  <a:ext uri="{0D108BD9-81ED-4DB2-BD59-A6C34878D82A}">
+                    <a16:rowId xmlns:a16="http://schemas.microsoft.com/office/drawing/2014/main" val="10005"/>
+                  </a:ext>
+                </a:extLst>
               </a:tr>
             </a:tbl>
           </a:graphicData>

</xml_diff>